<commit_message>
sync: 200k Zhenglong->office reclass surfaced; payroll analysis; v3.1 2026-09-18
</commit_message>
<xml_diff>
--- a/anxing/安幸_月度損益簡報_115年8月.pptx
+++ b/anxing/安幸_月度損益簡報_115年8月.pptx
@@ -7649,7 +7649,7 @@
                 <a:ea typeface="Microsoft JhengHei Light" pitchFamily="34" charset="-122"/>
                 <a:cs typeface="Microsoft JhengHei Light" pitchFamily="34" charset="-120"/>
               </a:rPr>
-              <a:t>薪資中樞:441,374 薪資全列此、內部僅回收 178,000。屬結構性,非經營惡化。</a:t>
+              <a:t>薪資中樞:薪資 441,374+自身營運 148,939;內部收入 464,710(含正隆 200,000)未足額覆蓋。結構性。</a:t>
             </a:r>
             <a:endParaRPr lang="en-US" sz="1050" dirty="0"/>
           </a:p>
@@ -8158,7 +8158,7 @@
         </p:nvSpPr>
         <p:spPr>
           <a:xfrm>
-            <a:off x="914400" y="1828800"/>
+            <a:off x="914400" y="1600200"/>
             <a:ext cx="2011680" cy="320040"/>
           </a:xfrm>
           <a:prstGeom prst="rect">
@@ -8183,7 +8183,7 @@
                 <a:ea typeface="Microsoft JhengHei Light" pitchFamily="34" charset="-122"/>
                 <a:cs typeface="Microsoft JhengHei Light" pitchFamily="34" charset="-120"/>
               </a:rPr>
-              <a:t>時兆  </a:t>
+              <a:t>正隆  </a:t>
             </a:r>
             <a:pPr indent="0" marL="0">
               <a:buNone/>
@@ -8197,7 +8197,7 @@
                 <a:ea typeface="Palatino Linotype" pitchFamily="34" charset="-122"/>
                 <a:cs typeface="Palatino Linotype" pitchFamily="34" charset="-120"/>
               </a:rPr>
-              <a:t>90,000</a:t>
+              <a:t>200,000</a:t>
             </a:r>
             <a:endParaRPr lang="en-US" sz="1150" dirty="0"/>
           </a:p>
@@ -8211,7 +8211,7 @@
         </p:nvSpPr>
         <p:spPr>
           <a:xfrm>
-            <a:off x="3063240" y="1975104"/>
+            <a:off x="3063240" y="1746504"/>
             <a:ext cx="1600200" cy="0"/>
           </a:xfrm>
           <a:prstGeom prst="line">
@@ -8235,7 +8235,7 @@
         </p:nvSpPr>
         <p:spPr>
           <a:xfrm>
-            <a:off x="914400" y="3017520"/>
+            <a:off x="914400" y="2377440"/>
             <a:ext cx="2011680" cy="320040"/>
           </a:xfrm>
           <a:prstGeom prst="rect">
@@ -8260,7 +8260,7 @@
                 <a:ea typeface="Microsoft JhengHei Light" pitchFamily="34" charset="-122"/>
                 <a:cs typeface="Microsoft JhengHei Light" pitchFamily="34" charset="-120"/>
               </a:rPr>
-              <a:t>開封  </a:t>
+              <a:t>時兆  </a:t>
             </a:r>
             <a:pPr indent="0" marL="0">
               <a:buNone/>
@@ -8274,7 +8274,7 @@
                 <a:ea typeface="Palatino Linotype" pitchFamily="34" charset="-122"/>
                 <a:cs typeface="Palatino Linotype" pitchFamily="34" charset="-120"/>
               </a:rPr>
-              <a:t>48,000</a:t>
+              <a:t>90,000</a:t>
             </a:r>
             <a:endParaRPr lang="en-US" sz="1150" dirty="0"/>
           </a:p>
@@ -8288,7 +8288,7 @@
         </p:nvSpPr>
         <p:spPr>
           <a:xfrm>
-            <a:off x="3063240" y="3163824"/>
+            <a:off x="3063240" y="2523744"/>
             <a:ext cx="1600200" cy="0"/>
           </a:xfrm>
           <a:prstGeom prst="line">
@@ -8312,7 +8312,7 @@
         </p:nvSpPr>
         <p:spPr>
           <a:xfrm>
-            <a:off x="914400" y="4206240"/>
+            <a:off x="914400" y="3154680"/>
             <a:ext cx="2011680" cy="320040"/>
           </a:xfrm>
           <a:prstGeom prst="rect">
@@ -8337,7 +8337,7 @@
                 <a:ea typeface="Microsoft JhengHei Light" pitchFamily="34" charset="-122"/>
                 <a:cs typeface="Microsoft JhengHei Light" pitchFamily="34" charset="-120"/>
               </a:rPr>
-              <a:t>JPR  </a:t>
+              <a:t>開封  </a:t>
             </a:r>
             <a:pPr indent="0" marL="0">
               <a:buNone/>
@@ -8351,7 +8351,7 @@
                 <a:ea typeface="Palatino Linotype" pitchFamily="34" charset="-122"/>
                 <a:cs typeface="Palatino Linotype" pitchFamily="34" charset="-120"/>
               </a:rPr>
-              <a:t>40,000</a:t>
+              <a:t>48,000</a:t>
             </a:r>
             <a:endParaRPr lang="en-US" sz="1150" dirty="0"/>
           </a:p>
@@ -8365,7 +8365,7 @@
         </p:nvSpPr>
         <p:spPr>
           <a:xfrm>
-            <a:off x="3063240" y="4352544"/>
+            <a:off x="3063240" y="3300984"/>
             <a:ext cx="1600200" cy="0"/>
           </a:xfrm>
           <a:prstGeom prst="line">
@@ -8383,13 +8383,143 @@
       </p:sp>
       <p:sp>
         <p:nvSpPr>
-          <p:cNvPr id="10" name="Shape 8"/>
+          <p:cNvPr id="10" name="Text 8"/>
+          <p:cNvSpPr txBox="1"/>
+          <p:nvPr/>
+        </p:nvSpPr>
+        <p:spPr>
+          <a:xfrm>
+            <a:off x="914400" y="3931920"/>
+            <a:ext cx="2011680" cy="320040"/>
+          </a:xfrm>
+          <a:prstGeom prst="rect">
+            <a:avLst/>
+          </a:prstGeom>
+          <a:noFill/>
+          <a:ln/>
+        </p:spPr>
+        <p:txBody>
+          <a:bodyPr wrap="square" lIns="0" tIns="0" rIns="0" bIns="0" rtlCol="0" anchor="ctr"/>
+          <a:lstStyle/>
+          <a:p>
+            <a:pPr indent="0" marL="0">
+              <a:buNone/>
+            </a:pPr>
+            <a:r>
+              <a:rPr lang="en-US" sz="1150" dirty="0">
+                <a:solidFill>
+                  <a:srgbClr val="221D17"/>
+                </a:solidFill>
+                <a:latin typeface="Microsoft JhengHei Light" pitchFamily="34" charset="0"/>
+                <a:ea typeface="Microsoft JhengHei Light" pitchFamily="34" charset="-122"/>
+                <a:cs typeface="Microsoft JhengHei Light" pitchFamily="34" charset="-120"/>
+              </a:rPr>
+              <a:t>JPR  </a:t>
+            </a:r>
+            <a:pPr indent="0" marL="0">
+              <a:buNone/>
+            </a:pPr>
+            <a:r>
+              <a:rPr lang="en-US" sz="1150" dirty="0">
+                <a:solidFill>
+                  <a:srgbClr val="4A443B"/>
+                </a:solidFill>
+                <a:latin typeface="Palatino Linotype" pitchFamily="34" charset="0"/>
+                <a:ea typeface="Palatino Linotype" pitchFamily="34" charset="-122"/>
+                <a:cs typeface="Palatino Linotype" pitchFamily="34" charset="-120"/>
+              </a:rPr>
+              <a:t>40,000</a:t>
+            </a:r>
+            <a:endParaRPr lang="en-US" sz="1150" dirty="0"/>
+          </a:p>
+        </p:txBody>
+      </p:sp>
+      <p:sp>
+        <p:nvSpPr>
+          <p:cNvPr id="11" name="Shape 9"/>
           <p:cNvSpPr/>
           <p:nvPr/>
         </p:nvSpPr>
         <p:spPr>
           <a:xfrm>
-            <a:off x="4846320" y="2468880"/>
+            <a:off x="3063240" y="4078224"/>
+            <a:ext cx="1600200" cy="0"/>
+          </a:xfrm>
+          <a:prstGeom prst="line">
+            <a:avLst/>
+          </a:prstGeom>
+          <a:noFill/>
+          <a:ln w="9525">
+            <a:solidFill>
+              <a:srgbClr val="A49E94"/>
+            </a:solidFill>
+            <a:prstDash val="solid"/>
+            <a:tailEnd type="triangle"/>
+          </a:ln>
+        </p:spPr>
+      </p:sp>
+      <p:sp>
+        <p:nvSpPr>
+          <p:cNvPr id="12" name="Text 10"/>
+          <p:cNvSpPr txBox="1"/>
+          <p:nvPr/>
+        </p:nvSpPr>
+        <p:spPr>
+          <a:xfrm>
+            <a:off x="914400" y="4617720"/>
+            <a:ext cx="2743200" cy="274320"/>
+          </a:xfrm>
+          <a:prstGeom prst="rect">
+            <a:avLst/>
+          </a:prstGeom>
+          <a:noFill/>
+          <a:ln/>
+        </p:spPr>
+        <p:txBody>
+          <a:bodyPr wrap="square" lIns="0" tIns="0" rIns="0" bIns="0" rtlCol="0" anchor="ctr"/>
+          <a:lstStyle/>
+          <a:p>
+            <a:pPr indent="0" marL="0">
+              <a:buNone/>
+            </a:pPr>
+            <a:r>
+              <a:rPr lang="en-US" sz="950" dirty="0">
+                <a:solidFill>
+                  <a:srgbClr val="A49E94"/>
+                </a:solidFill>
+                <a:latin typeface="Microsoft JhengHei Light" pitchFamily="34" charset="0"/>
+                <a:ea typeface="Microsoft JhengHei Light" pitchFamily="34" charset="-122"/>
+                <a:cs typeface="Microsoft JhengHei Light" pitchFamily="34" charset="-120"/>
+              </a:rPr>
+              <a:t>＋各案清潔費 </a:t>
+            </a:r>
+            <a:pPr indent="0" marL="0">
+              <a:buNone/>
+            </a:pPr>
+            <a:r>
+              <a:rPr lang="en-US" sz="950" dirty="0">
+                <a:solidFill>
+                  <a:srgbClr val="A49E94"/>
+                </a:solidFill>
+                <a:latin typeface="Palatino Linotype" pitchFamily="34" charset="0"/>
+                <a:ea typeface="Palatino Linotype" pitchFamily="34" charset="-122"/>
+                <a:cs typeface="Palatino Linotype" pitchFamily="34" charset="-120"/>
+              </a:rPr>
+              <a:t>87,510</a:t>
+            </a:r>
+            <a:endParaRPr lang="en-US" sz="950" dirty="0"/>
+          </a:p>
+        </p:txBody>
+      </p:sp>
+      <p:sp>
+        <p:nvSpPr>
+          <p:cNvPr id="13" name="Shape 11"/>
+          <p:cNvSpPr/>
+          <p:nvPr/>
+        </p:nvSpPr>
+        <p:spPr>
+          <a:xfrm>
+            <a:off x="4846320" y="2514600"/>
             <a:ext cx="3017520" cy="1371600"/>
           </a:xfrm>
           <a:prstGeom prst="rect">
@@ -8408,13 +8538,13 @@
       </p:sp>
       <p:sp>
         <p:nvSpPr>
-          <p:cNvPr id="11" name="Text 9"/>
-          <p:cNvSpPr txBox="1"/>
-          <p:nvPr/>
-        </p:nvSpPr>
-        <p:spPr>
-          <a:xfrm>
-            <a:off x="4846320" y="2651760"/>
+          <p:cNvPr id="14" name="Text 12"/>
+          <p:cNvSpPr txBox="1"/>
+          <p:nvPr/>
+        </p:nvSpPr>
+        <p:spPr>
+          <a:xfrm>
+            <a:off x="4846320" y="2697480"/>
             <a:ext cx="3017520" cy="365760"/>
           </a:xfrm>
           <a:prstGeom prst="rect">
@@ -8447,13 +8577,13 @@
       </p:sp>
       <p:sp>
         <p:nvSpPr>
-          <p:cNvPr id="12" name="Text 10"/>
-          <p:cNvSpPr txBox="1"/>
-          <p:nvPr/>
-        </p:nvSpPr>
-        <p:spPr>
-          <a:xfrm>
-            <a:off x="4846320" y="3063240"/>
+          <p:cNvPr id="15" name="Text 13"/>
+          <p:cNvSpPr txBox="1"/>
+          <p:nvPr/>
+        </p:nvSpPr>
+        <p:spPr>
+          <a:xfrm>
+            <a:off x="4846320" y="3108960"/>
             <a:ext cx="3017520" cy="320040"/>
           </a:xfrm>
           <a:prstGeom prst="rect">
@@ -8500,14 +8630,14 @@
       </p:sp>
       <p:sp>
         <p:nvSpPr>
-          <p:cNvPr id="13" name="Shape 11"/>
+          <p:cNvPr id="16" name="Shape 14"/>
           <p:cNvSpPr/>
           <p:nvPr/>
         </p:nvSpPr>
         <p:spPr>
           <a:xfrm>
-            <a:off x="7863840" y="3154680"/>
-            <a:ext cx="1371600" cy="0"/>
+            <a:off x="7863840" y="3200400"/>
+            <a:ext cx="1234440" cy="0"/>
           </a:xfrm>
           <a:prstGeom prst="line">
             <a:avLst/>
@@ -8524,14 +8654,14 @@
       </p:sp>
       <p:sp>
         <p:nvSpPr>
-          <p:cNvPr id="14" name="Text 12"/>
-          <p:cNvSpPr txBox="1"/>
-          <p:nvPr/>
-        </p:nvSpPr>
-        <p:spPr>
-          <a:xfrm>
-            <a:off x="9326880" y="2743200"/>
-            <a:ext cx="2194560" cy="1097280"/>
+          <p:cNvPr id="17" name="Text 15"/>
+          <p:cNvSpPr txBox="1"/>
+          <p:nvPr/>
+        </p:nvSpPr>
+        <p:spPr>
+          <a:xfrm>
+            <a:off x="9189720" y="2606040"/>
+            <a:ext cx="2286000" cy="1371600"/>
           </a:xfrm>
           <a:prstGeom prst="rect">
             <a:avLst/>
@@ -8558,7 +8688,7 @@
                 <a:ea typeface="Microsoft JhengHei Light" pitchFamily="34" charset="-122"/>
                 <a:cs typeface="Microsoft JhengHei Light" pitchFamily="34" charset="-120"/>
               </a:rPr>
-              <a:t>內部回收 </a:t>
+              <a:t>內部收入 </a:t>
             </a:r>
             <a:pPr indent="0" marL="0">
               <a:lnSpc>
@@ -8575,7 +8705,7 @@
                 <a:ea typeface="Palatino Linotype" pitchFamily="34" charset="-122"/>
                 <a:cs typeface="Palatino Linotype" pitchFamily="34" charset="-120"/>
               </a:rPr>
-              <a:t>178,000</a:t>
+              <a:t>464,710</a:t>
             </a:r>
             <a:pPr indent="0" marL="0">
               <a:lnSpc>
@@ -8601,7 +8731,7 @@
                 <a:ea typeface="Microsoft JhengHei Light" pitchFamily="34" charset="-122"/>
                 <a:cs typeface="Microsoft JhengHei Light" pitchFamily="34" charset="-120"/>
               </a:rPr>
-              <a:t>淨額 </a:t>
+              <a:t>總支出 </a:t>
             </a:r>
             <a:endParaRPr lang="en-US" sz="1100" dirty="0"/>
           </a:p>
@@ -8615,13 +8745,13 @@
             <a:r>
               <a:rPr lang="en-US" sz="1200" dirty="0">
                 <a:solidFill>
-                  <a:srgbClr val="A3543F"/>
+                  <a:srgbClr val="221D17"/>
                 </a:solidFill>
                 <a:latin typeface="Palatino Linotype" pitchFamily="34" charset="0"/>
                 <a:ea typeface="Palatino Linotype" pitchFamily="34" charset="-122"/>
                 <a:cs typeface="Palatino Linotype" pitchFamily="34" charset="-120"/>
               </a:rPr>
-              <a:t>−125,603</a:t>
+              <a:t>590,313</a:t>
             </a:r>
             <a:pPr indent="0" marL="0">
               <a:lnSpc>
@@ -8629,43 +8759,75 @@
               </a:lnSpc>
               <a:buNone/>
             </a:pPr>
-            <a:r>
-              <a:rPr lang="en-US" sz="950" dirty="0">
-                <a:solidFill>
-                  <a:srgbClr val="A49E94"/>
+            <a:endParaRPr lang="en-US" sz="1100" dirty="0"/>
+          </a:p>
+          <a:p>
+            <a:pPr indent="0" marL="0">
+              <a:lnSpc>
+                <a:spcPts val="2200"/>
+              </a:lnSpc>
+              <a:buNone/>
+            </a:pPr>
+            <a:r>
+              <a:rPr lang="en-US" sz="1100" dirty="0">
+                <a:solidFill>
+                  <a:srgbClr val="4A443B"/>
                 </a:solidFill>
                 <a:latin typeface="Microsoft JhengHei Light" pitchFamily="34" charset="0"/>
                 <a:ea typeface="Microsoft JhengHei Light" pitchFamily="34" charset="-122"/>
                 <a:cs typeface="Microsoft JhengHei Light" pitchFamily="34" charset="-120"/>
               </a:rPr>
-              <a:t> (結構性)</a:t>
+              <a:t>淨額 </a:t>
             </a:r>
             <a:endParaRPr lang="en-US" sz="1100" dirty="0"/>
           </a:p>
-        </p:txBody>
-      </p:sp>
-      <p:sp>
-        <p:nvSpPr>
-          <p:cNvPr id="15" name="Text 13"/>
-          <p:cNvSpPr txBox="1"/>
-          <p:nvPr/>
-        </p:nvSpPr>
-        <p:spPr>
-          <a:xfrm>
-            <a:off x="914400" y="5212080"/>
-            <a:ext cx="10332720" cy="457200"/>
-          </a:xfrm>
-          <a:prstGeom prst="rect">
-            <a:avLst/>
-          </a:prstGeom>
-          <a:noFill/>
-          <a:ln/>
-        </p:spPr>
-        <p:txBody>
-          <a:bodyPr wrap="square" lIns="0" tIns="0" rIns="0" bIns="0" rtlCol="0" anchor="ctr"/>
-          <a:lstStyle/>
-          <a:p>
-            <a:pPr indent="0" marL="0">
+          <a:p>
+            <a:pPr indent="0" marL="0">
+              <a:lnSpc>
+                <a:spcPts val="2200"/>
+              </a:lnSpc>
+              <a:buNone/>
+            </a:pPr>
+            <a:r>
+              <a:rPr lang="en-US" sz="1200" dirty="0">
+                <a:solidFill>
+                  <a:srgbClr val="A3543F"/>
+                </a:solidFill>
+                <a:latin typeface="Palatino Linotype" pitchFamily="34" charset="0"/>
+                <a:ea typeface="Palatino Linotype" pitchFamily="34" charset="-122"/>
+                <a:cs typeface="Palatino Linotype" pitchFamily="34" charset="-120"/>
+              </a:rPr>
+              <a:t>−125,603</a:t>
+            </a:r>
+            <a:endParaRPr lang="en-US" sz="1100" dirty="0"/>
+          </a:p>
+        </p:txBody>
+      </p:sp>
+      <p:sp>
+        <p:nvSpPr>
+          <p:cNvPr id="18" name="Text 16"/>
+          <p:cNvSpPr txBox="1"/>
+          <p:nvPr/>
+        </p:nvSpPr>
+        <p:spPr>
+          <a:xfrm>
+            <a:off x="914400" y="5257800"/>
+            <a:ext cx="10332720" cy="548640"/>
+          </a:xfrm>
+          <a:prstGeom prst="rect">
+            <a:avLst/>
+          </a:prstGeom>
+          <a:noFill/>
+          <a:ln/>
+        </p:spPr>
+        <p:txBody>
+          <a:bodyPr wrap="square" lIns="0" tIns="0" rIns="0" bIns="0" rtlCol="0" anchor="ctr"/>
+          <a:lstStyle/>
+          <a:p>
+            <a:pPr indent="0" marL="0">
+              <a:lnSpc>
+                <a:spcPts val="1900"/>
+              </a:lnSpc>
               <a:buNone/>
             </a:pPr>
             <a:r>
@@ -8677,7 +8839,7 @@
                 <a:ea typeface="Microsoft JhengHei Light" pitchFamily="34" charset="-122"/>
                 <a:cs typeface="Microsoft JhengHei Light" pitchFamily="34" charset="-120"/>
               </a:rPr>
-              <a:t>九人薪資集中列於辦公室;三案固定回付。合併損益不受影響——單看辦公室的赤字,是設計,不是失血。</a:t>
+              <a:t>四案固定回付 378,000+清潔費 87,510=內部收入 464,710;對上薪資 441,374 與自身營運費 148,939——缺口 125,603 是老闆自留的管理成本,合併中自動抵銷。</a:t>
             </a:r>
             <a:endParaRPr lang="en-US" sz="1100" dirty="0"/>
           </a:p>
@@ -8685,7 +8847,7 @@
       </p:sp>
       <p:sp>
         <p:nvSpPr>
-          <p:cNvPr id="16" name="Shape 14"/>
+          <p:cNvPr id="19" name="Shape 17"/>
           <p:cNvSpPr/>
           <p:nvPr/>
         </p:nvSpPr>
@@ -8708,7 +8870,7 @@
       </p:sp>
       <p:sp>
         <p:nvSpPr>
-          <p:cNvPr id="17" name="Text 15"/>
+          <p:cNvPr id="20" name="Text 18"/>
           <p:cNvSpPr txBox="1"/>
           <p:nvPr/>
         </p:nvSpPr>
@@ -8747,7 +8909,7 @@
       </p:sp>
       <p:sp>
         <p:nvSpPr>
-          <p:cNvPr id="18" name="Text 16"/>
+          <p:cNvPr id="21" name="Text 19"/>
           <p:cNvSpPr txBox="1"/>
           <p:nvPr/>
         </p:nvSpPr>

</xml_diff>